<commit_message>
Fix figure-0-flow.pptx refusing to open in PowerPoint
One endpoint of the feedback elbow was computed from a column width, which is
an Emu division and so a float. add_shape and add_textbox coerce their
arguments; add_connector writes them straight through, so the slide carried
`x="11804904.0"` — not a valid ST_Coordinate, which is an xsd:long. PowerPoint
declares the whole file corrupt over it.

python-pptx reads the bad file back without complaint and qlmanage renders it
fine, so neither the builder nor a visual check catches this. The verifier now
greps the slide XML for fractional x/y/cx/cy directly.

Co-Authored-By: Claude Opus 5 <noreply@anthropic.com>
</commit_message>
<xml_diff>
--- a/docs/architecture/figure-0-flow.pptx
+++ b/docs/architecture/figure-0-flow.pptx
@@ -8058,8 +8058,8 @@
         </p:nvCxnSpPr>
         <p:spPr>
           <a:xfrm flipH="1">
-            <a:off x="11804904.0" y="5760720"/>
-            <a:ext cx="228600.0" cy="0"/>
+            <a:off x="11804904" y="5760720"/>
+            <a:ext cx="228600" cy="0"/>
           </a:xfrm>
           <a:prstGeom prst="line">
             <a:avLst/>

</xml_diff>